<commit_message>
Rename the demo persona Kamala to Riya and name the team in full
Riya keeps Kamala's age, story and fictional label; the persona reports regenerate byte for byte, and the README, slides and video now say Riya and list Harshita Kumar and Eeshan Gupta.

Co-Authored-By: Claude Opus 5.5 <noreply@anthropic.com>
</commit_message>
<xml_diff>
--- a/Monarch_Vellore-Institute-of-Technology/deliverables/VrikkaTwin_slides.pptx
+++ b/Monarch_Vellore-Institute-of-Technology/deliverables/VrikkaTwin_slides.pptx
@@ -5183,7 +5183,7 @@
               </a:defRPr>
             </a:pPr>
             <a:r>
-              <a:t>Kamala (fictional), 68, Nagpur: the morning before</a:t>
+              <a:t>Riya (fictional), 68, Nagpur: the morning before</a:t>
             </a:r>
           </a:p>
         </p:txBody>
@@ -5266,7 +5266,7 @@
       </p:sp>
       <p:pic>
         <p:nvPicPr>
-          <p:cNvPr id="6" name="Picture 5" descr="kamala_risk.png"/>
+          <p:cNvPr id="6" name="Picture 5" descr="riya_risk.png"/>
           <p:cNvPicPr>
             <a:picLocks noChangeAspect="1"/>
           </p:cNvPicPr>
@@ -5290,7 +5290,7 @@
       </p:pic>
       <p:pic>
         <p:nvPicPr>
-          <p:cNvPr id="7" name="Picture 6" descr="kamala_whatif.png"/>
+          <p:cNvPr id="7" name="Picture 6" descr="riya_whatif.png"/>
           <p:cNvPicPr>
             <a:picLocks noChangeAspect="1"/>
           </p:cNvPicPr>
@@ -5527,7 +5527,7 @@
       </p:sp>
       <p:pic>
         <p:nvPicPr>
-          <p:cNvPr id="6" name="Picture 5" descr="kamala_slowclock.png"/>
+          <p:cNvPr id="6" name="Picture 5" descr="riya_slowclock.png"/>
           <p:cNvPicPr>
             <a:picLocks noChangeAspect="1"/>
           </p:cNvPicPr>
@@ -5582,7 +5582,7 @@
               </a:defRPr>
             </a:pPr>
             <a:r>
-              <a:t>• Kamala, eGFR in 10 years: 10-76 (wide: no serial labs yet)</a:t>
+              <a:t>• Riya, eGFR in 10 years: 10-76 (wide: no serial labs yet)</a:t>
             </a:r>
           </a:p>
           <a:p>

</xml_diff>